<commit_message>
Propositional Logic-2 added and part 1 updated
</commit_message>
<xml_diff>
--- a/Propositional Logic Part-1.pptx
+++ b/Propositional Logic Part-1.pptx
@@ -21,6 +21,7 @@
     <p:sldId id="266" r:id="rId12"/>
     <p:sldId id="267" r:id="rId13"/>
     <p:sldId id="268" r:id="rId14"/>
+    <p:sldId id="286" r:id="rId37"/>
     <p:sldId id="269" r:id="rId15"/>
     <p:sldId id="270" r:id="rId16"/>
     <p:sldId id="271" r:id="rId17"/>
@@ -237,7 +238,7 @@
           <a:p>
             <a:fld id="{A9BE1C7F-8531-4500-8F91-F3FAB5C6CE10}" type="datetimeFigureOut">
               <a:rPr lang="en-US" smtClean="0"/>
-              <a:t>10/26/2026</a:t>
+              <a:t>10/28/2026</a:t>
             </a:fld>
             <a:endParaRPr lang="en-US"/>
           </a:p>
@@ -1841,7 +1842,7 @@
           <a:p>
             <a:fld id="{5BCAD085-E8A6-8845-BD4E-CB4CCA059FC4}" type="datetimeFigureOut">
               <a:rPr lang="en-US" smtClean="0"/>
-              <a:t>10/26/2026</a:t>
+              <a:t>10/28/2026</a:t>
             </a:fld>
             <a:endParaRPr lang="en-US"/>
           </a:p>
@@ -2009,7 +2010,7 @@
           <a:p>
             <a:fld id="{5BCAD085-E8A6-8845-BD4E-CB4CCA059FC4}" type="datetimeFigureOut">
               <a:rPr lang="en-US" smtClean="0"/>
-              <a:t>10/26/2026</a:t>
+              <a:t>10/28/2026</a:t>
             </a:fld>
             <a:endParaRPr lang="en-US"/>
           </a:p>
@@ -2187,7 +2188,7 @@
           <a:p>
             <a:fld id="{5BCAD085-E8A6-8845-BD4E-CB4CCA059FC4}" type="datetimeFigureOut">
               <a:rPr lang="en-US" smtClean="0"/>
-              <a:t>10/26/2026</a:t>
+              <a:t>10/28/2026</a:t>
             </a:fld>
             <a:endParaRPr lang="en-US"/>
           </a:p>
@@ -2355,7 +2356,7 @@
           <a:p>
             <a:fld id="{5BCAD085-E8A6-8845-BD4E-CB4CCA059FC4}" type="datetimeFigureOut">
               <a:rPr lang="en-US" smtClean="0"/>
-              <a:t>10/26/2026</a:t>
+              <a:t>10/28/2026</a:t>
             </a:fld>
             <a:endParaRPr lang="en-US"/>
           </a:p>
@@ -2600,7 +2601,7 @@
           <a:p>
             <a:fld id="{5BCAD085-E8A6-8845-BD4E-CB4CCA059FC4}" type="datetimeFigureOut">
               <a:rPr lang="en-US" smtClean="0"/>
-              <a:t>10/26/2026</a:t>
+              <a:t>10/28/2026</a:t>
             </a:fld>
             <a:endParaRPr lang="en-US"/>
           </a:p>
@@ -2885,7 +2886,7 @@
           <a:p>
             <a:fld id="{5BCAD085-E8A6-8845-BD4E-CB4CCA059FC4}" type="datetimeFigureOut">
               <a:rPr lang="en-US" smtClean="0"/>
-              <a:t>10/26/2026</a:t>
+              <a:t>10/28/2026</a:t>
             </a:fld>
             <a:endParaRPr lang="en-US"/>
           </a:p>
@@ -3304,7 +3305,7 @@
           <a:p>
             <a:fld id="{5BCAD085-E8A6-8845-BD4E-CB4CCA059FC4}" type="datetimeFigureOut">
               <a:rPr lang="en-US" smtClean="0"/>
-              <a:t>10/26/2026</a:t>
+              <a:t>10/28/2026</a:t>
             </a:fld>
             <a:endParaRPr lang="en-US"/>
           </a:p>
@@ -3421,7 +3422,7 @@
           <a:p>
             <a:fld id="{5BCAD085-E8A6-8845-BD4E-CB4CCA059FC4}" type="datetimeFigureOut">
               <a:rPr lang="en-US" smtClean="0"/>
-              <a:t>10/26/2026</a:t>
+              <a:t>10/28/2026</a:t>
             </a:fld>
             <a:endParaRPr lang="en-US"/>
           </a:p>
@@ -3516,7 +3517,7 @@
           <a:p>
             <a:fld id="{5BCAD085-E8A6-8845-BD4E-CB4CCA059FC4}" type="datetimeFigureOut">
               <a:rPr lang="en-US" smtClean="0"/>
-              <a:t>10/26/2026</a:t>
+              <a:t>10/28/2026</a:t>
             </a:fld>
             <a:endParaRPr lang="en-US"/>
           </a:p>
@@ -3791,7 +3792,7 @@
           <a:p>
             <a:fld id="{5BCAD085-E8A6-8845-BD4E-CB4CCA059FC4}" type="datetimeFigureOut">
               <a:rPr lang="en-US" smtClean="0"/>
-              <a:t>10/26/2026</a:t>
+              <a:t>10/28/2026</a:t>
             </a:fld>
             <a:endParaRPr lang="en-US"/>
           </a:p>
@@ -4043,7 +4044,7 @@
           <a:p>
             <a:fld id="{5BCAD085-E8A6-8845-BD4E-CB4CCA059FC4}" type="datetimeFigureOut">
               <a:rPr lang="en-US" smtClean="0"/>
-              <a:t>10/26/2026</a:t>
+              <a:t>10/28/2026</a:t>
             </a:fld>
             <a:endParaRPr lang="en-US"/>
           </a:p>
@@ -4254,7 +4255,7 @@
           <a:p>
             <a:fld id="{5BCAD085-E8A6-8845-BD4E-CB4CCA059FC4}" type="datetimeFigureOut">
               <a:rPr lang="en-US" smtClean="0"/>
-              <a:t>10/26/2026</a:t>
+              <a:t>10/28/2026</a:t>
             </a:fld>
             <a:endParaRPr lang="en-US"/>
           </a:p>
@@ -11656,13 +11657,40 @@
               </a:spcAft>
             </a:pPr>
             <a:r>
-              <a:rPr sz="1500" b="0" i="0">
+              <a:rPr sz="1500" b="0" i="0" dirty="0">
                 <a:solidFill>
                   <a:srgbClr val="1B2D3E"/>
                 </a:solidFill>
                 <a:latin typeface="Segoe UI"/>
               </a:rPr>
-              <a:t>“The set menu comes with a drink or a dessert.”</a:t>
+              <a:t>“The set menu comes with a drink or a dessert</a:t>
+            </a:r>
+            <a:r>
+              <a:rPr lang="en-US" sz="1500" b="0" i="0">
+                <a:solidFill>
+                  <a:srgbClr val="1B2D3E"/>
+                </a:solidFill>
+                <a:latin typeface="Segoe UI"/>
+              </a:rPr>
+              <a:t>, but not </a:t>
+            </a:r>
+            <a:r>
+              <a:rPr lang="en-US" sz="1500" b="0" i="0" dirty="0">
+                <a:solidFill>
+                  <a:srgbClr val="1B2D3E"/>
+                </a:solidFill>
+                <a:latin typeface="Segoe UI"/>
+              </a:rPr>
+              <a:t>both</a:t>
+            </a:r>
+            <a:r>
+              <a:rPr sz="1500" b="0" i="0" dirty="0">
+                <a:solidFill>
+                  <a:srgbClr val="1B2D3E"/>
+                </a:solidFill>
+                <a:latin typeface="Segoe UI"/>
+              </a:rPr>
+              <a:t>.”</a:t>
             </a:r>
           </a:p>
         </p:txBody>
@@ -12430,7 +12458,7 @@
                 </a:solidFill>
                 <a:latin typeface="Segoe UI"/>
               </a:rPr>
-              <a:t>14</a:t>
+              <a:t>15</a:t>
             </a:r>
           </a:p>
         </p:txBody>
@@ -17308,7 +17336,7 @@
                 </a:solidFill>
                 <a:latin typeface="Segoe UI"/>
               </a:rPr>
-              <a:t>15</a:t>
+              <a:t>16</a:t>
             </a:r>
           </a:p>
         </p:txBody>
@@ -18549,7 +18577,7 @@
                 </a:solidFill>
                 <a:latin typeface="Segoe UI"/>
               </a:rPr>
-              <a:t>16</a:t>
+              <a:t>17</a:t>
             </a:r>
           </a:p>
         </p:txBody>
@@ -19812,7 +19840,7 @@
                 </a:solidFill>
                 <a:latin typeface="Segoe UI"/>
               </a:rPr>
-              <a:t>17</a:t>
+              <a:t>18</a:t>
             </a:r>
           </a:p>
         </p:txBody>
@@ -21871,7 +21899,7 @@
                 </a:solidFill>
                 <a:latin typeface="Segoe UI"/>
               </a:rPr>
-              <a:t>18</a:t>
+              <a:t>19</a:t>
             </a:r>
           </a:p>
         </p:txBody>
@@ -23794,7 +23822,7 @@
                 </a:solidFill>
                 <a:latin typeface="Segoe UI"/>
               </a:rPr>
-              <a:t>19</a:t>
+              <a:t>20</a:t>
             </a:r>
           </a:p>
         </p:txBody>
@@ -27130,7 +27158,7 @@
                 </a:solidFill>
                 <a:latin typeface="Segoe UI"/>
               </a:rPr>
-              <a:t>20</a:t>
+              <a:t>21</a:t>
             </a:r>
           </a:p>
         </p:txBody>
@@ -28352,7 +28380,7 @@
                 </a:solidFill>
                 <a:latin typeface="Segoe UI"/>
               </a:rPr>
-              <a:t>21</a:t>
+              <a:t>22</a:t>
             </a:r>
           </a:p>
         </p:txBody>
@@ -30504,7 +30532,7 @@
                 </a:solidFill>
                 <a:latin typeface="Segoe UI"/>
               </a:rPr>
-              <a:t>22</a:t>
+              <a:t>23</a:t>
             </a:r>
           </a:p>
         </p:txBody>
@@ -31986,7 +32014,7 @@
                 </a:solidFill>
                 <a:latin typeface="Segoe UI"/>
               </a:rPr>
-              <a:t>23</a:t>
+              <a:t>24</a:t>
             </a:r>
           </a:p>
         </p:txBody>
@@ -33885,7 +33913,7 @@
                 </a:solidFill>
                 <a:latin typeface="Segoe UI"/>
               </a:rPr>
-              <a:t>24</a:t>
+              <a:t>25</a:t>
             </a:r>
           </a:p>
         </p:txBody>
@@ -35993,7 +36021,7 @@
                 </a:solidFill>
                 <a:latin typeface="Segoe UI"/>
               </a:rPr>
-              <a:t>25</a:t>
+              <a:t>26</a:t>
             </a:r>
           </a:p>
         </p:txBody>
@@ -37280,7 +37308,7 @@
                 </a:solidFill>
                 <a:latin typeface="Segoe UI"/>
               </a:rPr>
-              <a:t>26</a:t>
+              <a:t>27</a:t>
             </a:r>
           </a:p>
         </p:txBody>
@@ -38652,7 +38680,7 @@
                 </a:solidFill>
                 <a:latin typeface="Segoe UI"/>
               </a:rPr>
-              <a:t>27</a:t>
+              <a:t>28</a:t>
             </a:r>
           </a:p>
         </p:txBody>
@@ -40006,7 +40034,7 @@
                 </a:solidFill>
                 <a:latin typeface="Segoe UI"/>
               </a:rPr>
-              <a:t>28</a:t>
+              <a:t>29</a:t>
             </a:r>
           </a:p>
         </p:txBody>
@@ -41072,7 +41100,7 @@
                 </a:solidFill>
                 <a:latin typeface="Segoe UI"/>
               </a:rPr>
-              <a:t>29</a:t>
+              <a:t>30</a:t>
             </a:r>
           </a:p>
         </p:txBody>
@@ -44436,6 +44464,1896 @@
           <a:p>
             <a:pPr algn="ctr"/>
             <a:endParaRPr/>
+          </a:p>
+        </p:txBody>
+      </p:sp>
+    </p:spTree>
+  </p:cSld>
+  <p:clrMapOvr>
+    <a:masterClrMapping/>
+  </p:clrMapOvr>
+</p:sld>
+</file>
+
+<file path=ppt/slides/slide31.xml><?xml version="1.0" encoding="utf-8"?>
+<p:sld xmlns:a="http://schemas.openxmlformats.org/drawingml/2006/main" xmlns:p="http://schemas.openxmlformats.org/presentationml/2006/main" xmlns:r="http://schemas.openxmlformats.org/officeDocument/2006/relationships">
+  <p:cSld>
+    <p:spTree>
+      <p:nvGrpSpPr>
+        <p:cNvPr id="1" name=""/>
+        <p:cNvGrpSpPr/>
+        <p:nvPr/>
+      </p:nvGrpSpPr>
+      <p:grpSpPr/>
+      <p:sp>
+        <p:nvSpPr>
+          <p:cNvPr id="2" name="TextBox 1"/>
+          <p:cNvSpPr txBox="1"/>
+          <p:nvPr/>
+        </p:nvSpPr>
+        <p:spPr>
+          <a:xfrm>
+            <a:off x="658368" y="402336"/>
+            <a:ext cx="10874959" cy="237744"/>
+          </a:xfrm>
+          <a:prstGeom prst="rect">
+            <a:avLst/>
+          </a:prstGeom>
+          <a:noFill/>
+        </p:spPr>
+        <p:txBody>
+          <a:bodyPr wrap="square" lIns="0" tIns="0" rIns="0" bIns="0" anchor="t"/>
+          <a:lstStyle/>
+          <a:p>
+            <a:pPr algn="l">
+              <a:lnSpc>
+                <a:spcPct val="95000"/>
+              </a:lnSpc>
+              <a:spcBef>
+                <a:spcPts val="0"/>
+              </a:spcBef>
+              <a:spcAft>
+                <a:spcPts val="0"/>
+              </a:spcAft>
+            </a:pPr>
+            <a:r>
+              <a:rPr sz="1050" b="1" i="0">
+                <a:solidFill>
+                  <a:srgbClr val="F07B1D"/>
+                </a:solidFill>
+                <a:latin typeface="Segoe UI"/>
+              </a:rPr>
+              <a:t>∨ VERSUS ⊕</a:t>
+            </a:r>
+          </a:p>
+        </p:txBody>
+      </p:sp>
+      <p:sp>
+        <p:nvSpPr>
+          <p:cNvPr id="3" name="TextBox 2"/>
+          <p:cNvSpPr txBox="1"/>
+          <p:nvPr/>
+        </p:nvSpPr>
+        <p:spPr>
+          <a:xfrm>
+            <a:off x="658368" y="676656"/>
+            <a:ext cx="10874959" cy="566928"/>
+          </a:xfrm>
+          <a:prstGeom prst="rect">
+            <a:avLst/>
+          </a:prstGeom>
+          <a:noFill/>
+        </p:spPr>
+        <p:txBody>
+          <a:bodyPr wrap="square" lIns="0" tIns="0" rIns="0" bIns="0" anchor="t"/>
+          <a:lstStyle/>
+          <a:p>
+            <a:pPr algn="l">
+              <a:lnSpc>
+                <a:spcPct val="100000"/>
+              </a:lnSpc>
+              <a:spcBef>
+                <a:spcPts val="0"/>
+              </a:spcBef>
+              <a:spcAft>
+                <a:spcPts val="0"/>
+              </a:spcAft>
+            </a:pPr>
+            <a:r>
+              <a:rPr sz="2800" b="1" i="0">
+                <a:solidFill>
+                  <a:srgbClr val="102A43"/>
+                </a:solidFill>
+                <a:latin typeface="Segoe UI"/>
+              </a:rPr>
+              <a:t>More examples: which “or” is it?</a:t>
+            </a:r>
+          </a:p>
+        </p:txBody>
+      </p:sp>
+      <p:sp>
+        <p:nvSpPr>
+          <p:cNvPr id="4" name="Rectangle 3"/>
+          <p:cNvSpPr/>
+          <p:nvPr/>
+        </p:nvSpPr>
+        <p:spPr>
+          <a:xfrm>
+            <a:off x="658368" y="1316736"/>
+            <a:ext cx="841248" cy="41148"/>
+          </a:xfrm>
+          <a:prstGeom prst="rect">
+            <a:avLst/>
+          </a:prstGeom>
+          <a:solidFill>
+            <a:srgbClr val="F07B1D"/>
+          </a:solidFill>
+          <a:ln>
+            <a:noFill/>
+          </a:ln>
+          <a:effectLst/>
+        </p:spPr>
+        <p:style>
+          <a:lnRef idx="1">
+            <a:schemeClr val="accent1"/>
+          </a:lnRef>
+          <a:fillRef idx="3">
+            <a:schemeClr val="accent1"/>
+          </a:fillRef>
+          <a:effectRef idx="2">
+            <a:schemeClr val="accent1"/>
+          </a:effectRef>
+          <a:fontRef idx="minor">
+            <a:schemeClr val="lt1"/>
+          </a:fontRef>
+        </p:style>
+        <p:txBody>
+          <a:bodyPr wrap="square" lIns="146304" tIns="73152" rIns="146304" bIns="73152" rtlCol="0" anchor="ctr"/>
+          <a:lstStyle/>
+          <a:p>
+            <a:pPr algn="ctr"/>
+            <a:endParaRPr/>
+          </a:p>
+        </p:txBody>
+      </p:sp>
+      <p:sp>
+        <p:nvSpPr>
+          <p:cNvPr id="5" name="Rectangle 4"/>
+          <p:cNvSpPr/>
+          <p:nvPr/>
+        </p:nvSpPr>
+        <p:spPr>
+          <a:xfrm>
+            <a:off x="1499616" y="1329537"/>
+            <a:ext cx="10033711" cy="14630"/>
+          </a:xfrm>
+          <a:prstGeom prst="rect">
+            <a:avLst/>
+          </a:prstGeom>
+          <a:solidFill>
+            <a:srgbClr val="D7E1EA"/>
+          </a:solidFill>
+          <a:ln>
+            <a:noFill/>
+          </a:ln>
+          <a:effectLst/>
+        </p:spPr>
+        <p:style>
+          <a:lnRef idx="1">
+            <a:schemeClr val="accent1"/>
+          </a:lnRef>
+          <a:fillRef idx="3">
+            <a:schemeClr val="accent1"/>
+          </a:fillRef>
+          <a:effectRef idx="2">
+            <a:schemeClr val="accent1"/>
+          </a:effectRef>
+          <a:fontRef idx="minor">
+            <a:schemeClr val="lt1"/>
+          </a:fontRef>
+        </p:style>
+        <p:txBody>
+          <a:bodyPr wrap="square" lIns="146304" tIns="73152" rIns="146304" bIns="73152" rtlCol="0" anchor="ctr"/>
+          <a:lstStyle/>
+          <a:p>
+            <a:pPr algn="ctr"/>
+            <a:endParaRPr/>
+          </a:p>
+        </p:txBody>
+      </p:sp>
+      <p:sp>
+        <p:nvSpPr>
+          <p:cNvPr id="6" name="TextBox 5"/>
+          <p:cNvSpPr txBox="1"/>
+          <p:nvPr/>
+        </p:nvSpPr>
+        <p:spPr>
+          <a:xfrm>
+            <a:off x="658368" y="6382512"/>
+            <a:ext cx="7612471" cy="274320"/>
+          </a:xfrm>
+          <a:prstGeom prst="rect">
+            <a:avLst/>
+          </a:prstGeom>
+          <a:noFill/>
+        </p:spPr>
+        <p:txBody>
+          <a:bodyPr wrap="square" lIns="0" tIns="0" rIns="0" bIns="0" anchor="t"/>
+          <a:lstStyle/>
+          <a:p>
+            <a:pPr algn="l">
+              <a:lnSpc>
+                <a:spcPct val="95000"/>
+              </a:lnSpc>
+              <a:spcBef>
+                <a:spcPts val="0"/>
+              </a:spcBef>
+              <a:spcAft>
+                <a:spcPts val="0"/>
+              </a:spcAft>
+            </a:pPr>
+            <a:r>
+              <a:rPr sz="950" b="0" i="0">
+                <a:solidFill>
+                  <a:srgbClr val="5F7388"/>
+                </a:solidFill>
+                <a:latin typeface="Segoe UI"/>
+              </a:rPr>
+              <a:t>Masnoon Muztahid  ·  Lecturer, Dept. of CSE, UIU  ·  CSE 2213</a:t>
+            </a:r>
+          </a:p>
+        </p:txBody>
+      </p:sp>
+      <p:sp>
+        <p:nvSpPr>
+          <p:cNvPr id="7" name="TextBox 6"/>
+          <p:cNvSpPr txBox="1"/>
+          <p:nvPr/>
+        </p:nvSpPr>
+        <p:spPr>
+          <a:xfrm>
+            <a:off x="10436047" y="6382512"/>
+            <a:ext cx="1097280" cy="274320"/>
+          </a:xfrm>
+          <a:prstGeom prst="rect">
+            <a:avLst/>
+          </a:prstGeom>
+          <a:noFill/>
+        </p:spPr>
+        <p:txBody>
+          <a:bodyPr wrap="square" lIns="0" tIns="0" rIns="0" bIns="0" anchor="t"/>
+          <a:lstStyle/>
+          <a:p>
+            <a:pPr algn="r">
+              <a:lnSpc>
+                <a:spcPct val="95000"/>
+              </a:lnSpc>
+              <a:spcBef>
+                <a:spcPts val="0"/>
+              </a:spcBef>
+              <a:spcAft>
+                <a:spcPts val="0"/>
+              </a:spcAft>
+            </a:pPr>
+            <a:r>
+              <a:rPr sz="1050" b="1" i="0">
+                <a:solidFill>
+                  <a:srgbClr val="5F7388"/>
+                </a:solidFill>
+                <a:latin typeface="Segoe UI"/>
+              </a:rPr>
+              <a:t>14</a:t>
+            </a:r>
+          </a:p>
+        </p:txBody>
+      </p:sp>
+      <p:sp>
+        <p:nvSpPr>
+          <p:cNvPr id="101" name="Shape 101"/>
+          <p:cNvSpPr/>
+          <p:nvPr/>
+        </p:nvSpPr>
+        <p:spPr>
+          <a:xfrm>
+            <a:off x="658368" y="1600200"/>
+            <a:ext cx="5163159" cy="640080"/>
+          </a:xfrm>
+          <a:prstGeom prst="roundRect">
+            <a:avLst>
+              <a:gd name="adj" fmla="val 6000"/>
+            </a:avLst>
+          </a:prstGeom>
+          <a:solidFill>
+            <a:srgbClr val="ECF7F2"/>
+          </a:solidFill>
+          <a:ln>
+            <a:noFill/>
+          </a:ln>
+          <a:effectLst/>
+        </p:spPr>
+        <p:style>
+          <a:lnRef idx="1">
+            <a:schemeClr val="accent1"/>
+          </a:lnRef>
+          <a:fillRef idx="3">
+            <a:schemeClr val="accent1"/>
+          </a:fillRef>
+          <a:effectRef idx="2">
+            <a:schemeClr val="accent1"/>
+          </a:effectRef>
+          <a:fontRef idx="minor">
+            <a:schemeClr val="lt1"/>
+          </a:fontRef>
+        </p:style>
+        <p:txBody>
+          <a:bodyPr wrap="square" rtlCol="0" anchor="ctr"/>
+          <a:lstStyle/>
+          <a:p>
+            <a:pPr algn="ctr"/>
+            <a:endParaRPr/>
+          </a:p>
+        </p:txBody>
+      </p:sp>
+      <p:sp>
+        <p:nvSpPr>
+          <p:cNvPr id="102" name="TextBox 102"/>
+          <p:cNvSpPr txBox="1"/>
+          <p:nvPr/>
+        </p:nvSpPr>
+        <p:spPr>
+          <a:xfrm>
+            <a:off x="978408" y="1600200"/>
+            <a:ext cx="4523079" cy="640080"/>
+          </a:xfrm>
+          <a:prstGeom prst="rect">
+            <a:avLst/>
+          </a:prstGeom>
+          <a:noFill/>
+        </p:spPr>
+        <p:txBody>
+          <a:bodyPr wrap="square" lIns="0" tIns="0" rIns="0" bIns="0" anchor="ctr">
+            <a:normAutofit/>
+          </a:bodyPr>
+          <a:lstStyle/>
+          <a:p>
+            <a:pPr algn="l">
+              <a:lnSpc>
+                <a:spcPct val="95000"/>
+              </a:lnSpc>
+              <a:spcBef>
+                <a:spcPts val="0"/>
+              </a:spcBef>
+              <a:spcAft>
+                <a:spcPts val="0"/>
+              </a:spcAft>
+            </a:pPr>
+            <a:r>
+              <a:rPr lang="en-US" sz="1700" b="1" i="0" dirty="0">
+                <a:solidFill>
+                  <a:srgbClr val="0E8F7E"/>
+                </a:solidFill>
+                <a:latin typeface="Segoe UI"/>
+                <a:cs typeface="Segoe UI"/>
+              </a:rPr>
+              <a:t>Inclusive  </a:t>
+            </a:r>
+            <a:r>
+              <a:rPr lang="en-US" sz="1800" b="1" i="0" dirty="0">
+                <a:solidFill>
+                  <a:srgbClr val="1F6FB2"/>
+                </a:solidFill>
+                <a:latin typeface="Cambria Math"/>
+                <a:cs typeface="Cambria Math"/>
+              </a:rPr>
+              <a:t>∨</a:t>
+            </a:r>
+            <a:r>
+              <a:rPr lang="en-US" sz="1300" b="0" i="0" dirty="0">
+                <a:solidFill>
+                  <a:srgbClr val="1B2D3E"/>
+                </a:solidFill>
+                <a:latin typeface="Segoe UI"/>
+                <a:cs typeface="Segoe UI"/>
+              </a:rPr>
+              <a:t>   “at least one” — both is fine</a:t>
+            </a:r>
+          </a:p>
+        </p:txBody>
+      </p:sp>
+      <p:sp>
+        <p:nvSpPr>
+          <p:cNvPr id="103" name="Shape 103"/>
+          <p:cNvSpPr/>
+          <p:nvPr/>
+        </p:nvSpPr>
+        <p:spPr>
+          <a:xfrm>
+            <a:off x="658368" y="2377440"/>
+            <a:ext cx="5163159" cy="868680"/>
+          </a:xfrm>
+          <a:prstGeom prst="roundRect">
+            <a:avLst>
+              <a:gd name="adj" fmla="val 6000"/>
+            </a:avLst>
+          </a:prstGeom>
+          <a:solidFill>
+            <a:srgbClr val="FFFFFF"/>
+          </a:solidFill>
+          <a:ln w="12700">
+            <a:solidFill>
+              <a:srgbClr val="D7E1EA"/>
+            </a:solidFill>
+          </a:ln>
+          <a:effectLst/>
+        </p:spPr>
+        <p:style>
+          <a:lnRef idx="1">
+            <a:schemeClr val="accent1"/>
+          </a:lnRef>
+          <a:fillRef idx="3">
+            <a:schemeClr val="accent1"/>
+          </a:fillRef>
+          <a:effectRef idx="2">
+            <a:schemeClr val="accent1"/>
+          </a:effectRef>
+          <a:fontRef idx="minor">
+            <a:schemeClr val="lt1"/>
+          </a:fontRef>
+        </p:style>
+        <p:txBody>
+          <a:bodyPr wrap="square" rtlCol="0" anchor="ctr"/>
+          <a:lstStyle/>
+          <a:p>
+            <a:pPr algn="ctr"/>
+            <a:endParaRPr/>
+          </a:p>
+        </p:txBody>
+      </p:sp>
+      <p:sp>
+        <p:nvSpPr>
+          <p:cNvPr id="104" name="Shape 104"/>
+          <p:cNvSpPr/>
+          <p:nvPr/>
+        </p:nvSpPr>
+        <p:spPr>
+          <a:xfrm>
+            <a:off x="658368" y="2377440"/>
+            <a:ext cx="64008" cy="868680"/>
+          </a:xfrm>
+          <a:prstGeom prst="rect">
+            <a:avLst/>
+          </a:prstGeom>
+          <a:solidFill>
+            <a:srgbClr val="0E8F7E"/>
+          </a:solidFill>
+          <a:ln>
+            <a:noFill/>
+          </a:ln>
+          <a:effectLst/>
+        </p:spPr>
+        <p:style>
+          <a:lnRef idx="1">
+            <a:schemeClr val="accent1"/>
+          </a:lnRef>
+          <a:fillRef idx="3">
+            <a:schemeClr val="accent1"/>
+          </a:fillRef>
+          <a:effectRef idx="2">
+            <a:schemeClr val="accent1"/>
+          </a:effectRef>
+          <a:fontRef idx="minor">
+            <a:schemeClr val="lt1"/>
+          </a:fontRef>
+        </p:style>
+        <p:txBody>
+          <a:bodyPr wrap="square" rtlCol="0" anchor="ctr"/>
+          <a:lstStyle/>
+          <a:p>
+            <a:pPr algn="ctr"/>
+            <a:endParaRPr/>
+          </a:p>
+        </p:txBody>
+      </p:sp>
+      <p:sp>
+        <p:nvSpPr>
+          <p:cNvPr id="105" name="TextBox 105"/>
+          <p:cNvSpPr txBox="1"/>
+          <p:nvPr/>
+        </p:nvSpPr>
+        <p:spPr>
+          <a:xfrm>
+            <a:off x="932688" y="2377440"/>
+            <a:ext cx="4705959" cy="868680"/>
+          </a:xfrm>
+          <a:prstGeom prst="rect">
+            <a:avLst/>
+          </a:prstGeom>
+          <a:noFill/>
+        </p:spPr>
+        <p:txBody>
+          <a:bodyPr wrap="square" lIns="0" tIns="0" rIns="0" bIns="0" anchor="ctr">
+            <a:normAutofit/>
+          </a:bodyPr>
+          <a:lstStyle/>
+          <a:p>
+            <a:pPr algn="l">
+              <a:lnSpc>
+                <a:spcPct val="95000"/>
+              </a:lnSpc>
+              <a:spcBef>
+                <a:spcPts val="0"/>
+              </a:spcBef>
+              <a:spcAft>
+                <a:spcPts val="300"/>
+              </a:spcAft>
+            </a:pPr>
+            <a:r>
+              <a:rPr lang="en-US" sz="1350" b="0" i="0" dirty="0">
+                <a:solidFill>
+                  <a:srgbClr val="1B2D3E"/>
+                </a:solidFill>
+                <a:latin typeface="Segoe UI"/>
+                <a:cs typeface="Segoe UI"/>
+              </a:rPr>
+              <a:t>“To apply for a PhD program, you need to have IELTS or TOEFL scores.”</a:t>
+            </a:r>
+          </a:p>
+          <a:p>
+            <a:pPr algn="l">
+              <a:lnSpc>
+                <a:spcPct val="95000"/>
+              </a:lnSpc>
+              <a:spcBef>
+                <a:spcPts val="0"/>
+              </a:spcBef>
+              <a:spcAft>
+                <a:spcPts val="0"/>
+              </a:spcAft>
+            </a:pPr>
+            <a:r>
+              <a:rPr lang="en-US" sz="1200" b="1" i="0" dirty="0">
+                <a:solidFill>
+                  <a:srgbClr val="0E8F7E"/>
+                </a:solidFill>
+                <a:latin typeface="Segoe UI"/>
+                <a:cs typeface="Segoe UI"/>
+              </a:rPr>
+              <a:t>Having both scores is fine. → </a:t>
+            </a:r>
+            <a:r>
+              <a:rPr lang="en-US" sz="1300" b="1" i="0" dirty="0">
+                <a:solidFill>
+                  <a:srgbClr val="1F6FB2"/>
+                </a:solidFill>
+                <a:latin typeface="Cambria Math"/>
+                <a:cs typeface="Cambria Math"/>
+              </a:rPr>
+              <a:t>∨</a:t>
+            </a:r>
+          </a:p>
+        </p:txBody>
+      </p:sp>
+      <p:sp>
+        <p:nvSpPr>
+          <p:cNvPr id="106" name="Shape 106"/>
+          <p:cNvSpPr/>
+          <p:nvPr/>
+        </p:nvSpPr>
+        <p:spPr>
+          <a:xfrm>
+            <a:off x="658368" y="3328416"/>
+            <a:ext cx="5163159" cy="868680"/>
+          </a:xfrm>
+          <a:prstGeom prst="roundRect">
+            <a:avLst>
+              <a:gd name="adj" fmla="val 6000"/>
+            </a:avLst>
+          </a:prstGeom>
+          <a:solidFill>
+            <a:srgbClr val="F3F7FA"/>
+          </a:solidFill>
+          <a:ln w="12700">
+            <a:solidFill>
+              <a:srgbClr val="D7E1EA"/>
+            </a:solidFill>
+          </a:ln>
+          <a:effectLst/>
+        </p:spPr>
+        <p:style>
+          <a:lnRef idx="1">
+            <a:schemeClr val="accent1"/>
+          </a:lnRef>
+          <a:fillRef idx="3">
+            <a:schemeClr val="accent1"/>
+          </a:fillRef>
+          <a:effectRef idx="2">
+            <a:schemeClr val="accent1"/>
+          </a:effectRef>
+          <a:fontRef idx="minor">
+            <a:schemeClr val="lt1"/>
+          </a:fontRef>
+        </p:style>
+        <p:txBody>
+          <a:bodyPr wrap="square" rtlCol="0" anchor="ctr"/>
+          <a:lstStyle/>
+          <a:p>
+            <a:pPr algn="ctr"/>
+            <a:endParaRPr/>
+          </a:p>
+        </p:txBody>
+      </p:sp>
+      <p:sp>
+        <p:nvSpPr>
+          <p:cNvPr id="107" name="Shape 107"/>
+          <p:cNvSpPr/>
+          <p:nvPr/>
+        </p:nvSpPr>
+        <p:spPr>
+          <a:xfrm>
+            <a:off x="658368" y="3328416"/>
+            <a:ext cx="64008" cy="868680"/>
+          </a:xfrm>
+          <a:prstGeom prst="rect">
+            <a:avLst/>
+          </a:prstGeom>
+          <a:solidFill>
+            <a:srgbClr val="0E8F7E"/>
+          </a:solidFill>
+          <a:ln>
+            <a:noFill/>
+          </a:ln>
+          <a:effectLst/>
+        </p:spPr>
+        <p:style>
+          <a:lnRef idx="1">
+            <a:schemeClr val="accent1"/>
+          </a:lnRef>
+          <a:fillRef idx="3">
+            <a:schemeClr val="accent1"/>
+          </a:fillRef>
+          <a:effectRef idx="2">
+            <a:schemeClr val="accent1"/>
+          </a:effectRef>
+          <a:fontRef idx="minor">
+            <a:schemeClr val="lt1"/>
+          </a:fontRef>
+        </p:style>
+        <p:txBody>
+          <a:bodyPr wrap="square" rtlCol="0" anchor="ctr"/>
+          <a:lstStyle/>
+          <a:p>
+            <a:pPr algn="ctr"/>
+            <a:endParaRPr/>
+          </a:p>
+        </p:txBody>
+      </p:sp>
+      <p:sp>
+        <p:nvSpPr>
+          <p:cNvPr id="108" name="TextBox 108"/>
+          <p:cNvSpPr txBox="1"/>
+          <p:nvPr/>
+        </p:nvSpPr>
+        <p:spPr>
+          <a:xfrm>
+            <a:off x="932688" y="3328416"/>
+            <a:ext cx="4705959" cy="868680"/>
+          </a:xfrm>
+          <a:prstGeom prst="rect">
+            <a:avLst/>
+          </a:prstGeom>
+          <a:noFill/>
+        </p:spPr>
+        <p:txBody>
+          <a:bodyPr wrap="square" lIns="0" tIns="0" rIns="0" bIns="0" anchor="ctr">
+            <a:normAutofit/>
+          </a:bodyPr>
+          <a:lstStyle/>
+          <a:p>
+            <a:pPr algn="l">
+              <a:lnSpc>
+                <a:spcPct val="95000"/>
+              </a:lnSpc>
+              <a:spcBef>
+                <a:spcPts val="0"/>
+              </a:spcBef>
+              <a:spcAft>
+                <a:spcPts val="300"/>
+              </a:spcAft>
+            </a:pPr>
+            <a:r>
+              <a:rPr lang="en-US" sz="1350" b="0" i="0" dirty="0">
+                <a:solidFill>
+                  <a:srgbClr val="1B2D3E"/>
+                </a:solidFill>
+                <a:latin typeface="Segoe UI"/>
+                <a:cs typeface="Segoe UI"/>
+              </a:rPr>
+              <a:t>“You can contact the instructor through email or WhatsApp.”</a:t>
+            </a:r>
+          </a:p>
+          <a:p>
+            <a:pPr algn="l">
+              <a:lnSpc>
+                <a:spcPct val="95000"/>
+              </a:lnSpc>
+              <a:spcBef>
+                <a:spcPts val="0"/>
+              </a:spcBef>
+              <a:spcAft>
+                <a:spcPts val="0"/>
+              </a:spcAft>
+            </a:pPr>
+            <a:r>
+              <a:rPr lang="en-US" sz="1200" b="1" i="0" dirty="0">
+                <a:solidFill>
+                  <a:srgbClr val="0E8F7E"/>
+                </a:solidFill>
+                <a:latin typeface="Segoe UI"/>
+                <a:cs typeface="Segoe UI"/>
+              </a:rPr>
+              <a:t>Using both works too. → </a:t>
+            </a:r>
+            <a:r>
+              <a:rPr lang="en-US" sz="1300" b="1" i="0" dirty="0">
+                <a:solidFill>
+                  <a:srgbClr val="1F6FB2"/>
+                </a:solidFill>
+                <a:latin typeface="Cambria Math"/>
+                <a:cs typeface="Cambria Math"/>
+              </a:rPr>
+              <a:t>∨</a:t>
+            </a:r>
+          </a:p>
+        </p:txBody>
+      </p:sp>
+      <p:sp>
+        <p:nvSpPr>
+          <p:cNvPr id="109" name="Shape 109"/>
+          <p:cNvSpPr/>
+          <p:nvPr/>
+        </p:nvSpPr>
+        <p:spPr>
+          <a:xfrm>
+            <a:off x="658368" y="4279392"/>
+            <a:ext cx="5163159" cy="868680"/>
+          </a:xfrm>
+          <a:prstGeom prst="roundRect">
+            <a:avLst>
+              <a:gd name="adj" fmla="val 6000"/>
+            </a:avLst>
+          </a:prstGeom>
+          <a:solidFill>
+            <a:srgbClr val="FFFFFF"/>
+          </a:solidFill>
+          <a:ln w="12700">
+            <a:solidFill>
+              <a:srgbClr val="D7E1EA"/>
+            </a:solidFill>
+          </a:ln>
+          <a:effectLst/>
+        </p:spPr>
+        <p:style>
+          <a:lnRef idx="1">
+            <a:schemeClr val="accent1"/>
+          </a:lnRef>
+          <a:fillRef idx="3">
+            <a:schemeClr val="accent1"/>
+          </a:fillRef>
+          <a:effectRef idx="2">
+            <a:schemeClr val="accent1"/>
+          </a:effectRef>
+          <a:fontRef idx="minor">
+            <a:schemeClr val="lt1"/>
+          </a:fontRef>
+        </p:style>
+        <p:txBody>
+          <a:bodyPr wrap="square" rtlCol="0" anchor="ctr"/>
+          <a:lstStyle/>
+          <a:p>
+            <a:pPr algn="ctr"/>
+            <a:endParaRPr/>
+          </a:p>
+        </p:txBody>
+      </p:sp>
+      <p:sp>
+        <p:nvSpPr>
+          <p:cNvPr id="110" name="Shape 110"/>
+          <p:cNvSpPr/>
+          <p:nvPr/>
+        </p:nvSpPr>
+        <p:spPr>
+          <a:xfrm>
+            <a:off x="658368" y="4279392"/>
+            <a:ext cx="64008" cy="868680"/>
+          </a:xfrm>
+          <a:prstGeom prst="rect">
+            <a:avLst/>
+          </a:prstGeom>
+          <a:solidFill>
+            <a:srgbClr val="0E8F7E"/>
+          </a:solidFill>
+          <a:ln>
+            <a:noFill/>
+          </a:ln>
+          <a:effectLst/>
+        </p:spPr>
+        <p:style>
+          <a:lnRef idx="1">
+            <a:schemeClr val="accent1"/>
+          </a:lnRef>
+          <a:fillRef idx="3">
+            <a:schemeClr val="accent1"/>
+          </a:fillRef>
+          <a:effectRef idx="2">
+            <a:schemeClr val="accent1"/>
+          </a:effectRef>
+          <a:fontRef idx="minor">
+            <a:schemeClr val="lt1"/>
+          </a:fontRef>
+        </p:style>
+        <p:txBody>
+          <a:bodyPr wrap="square" rtlCol="0" anchor="ctr"/>
+          <a:lstStyle/>
+          <a:p>
+            <a:pPr algn="ctr"/>
+            <a:endParaRPr/>
+          </a:p>
+        </p:txBody>
+      </p:sp>
+      <p:sp>
+        <p:nvSpPr>
+          <p:cNvPr id="111" name="TextBox 111"/>
+          <p:cNvSpPr txBox="1"/>
+          <p:nvPr/>
+        </p:nvSpPr>
+        <p:spPr>
+          <a:xfrm>
+            <a:off x="932688" y="4279392"/>
+            <a:ext cx="4705959" cy="868680"/>
+          </a:xfrm>
+          <a:prstGeom prst="rect">
+            <a:avLst/>
+          </a:prstGeom>
+          <a:noFill/>
+        </p:spPr>
+        <p:txBody>
+          <a:bodyPr wrap="square" lIns="0" tIns="0" rIns="0" bIns="0" anchor="ctr">
+            <a:normAutofit/>
+          </a:bodyPr>
+          <a:lstStyle/>
+          <a:p>
+            <a:pPr algn="l">
+              <a:lnSpc>
+                <a:spcPct val="95000"/>
+              </a:lnSpc>
+              <a:spcBef>
+                <a:spcPts val="0"/>
+              </a:spcBef>
+              <a:spcAft>
+                <a:spcPts val="300"/>
+              </a:spcAft>
+            </a:pPr>
+            <a:r>
+              <a:rPr lang="en-US" sz="1350" b="0" i="0" dirty="0">
+                <a:solidFill>
+                  <a:srgbClr val="1B2D3E"/>
+                </a:solidFill>
+                <a:latin typeface="Segoe UI"/>
+                <a:cs typeface="Segoe UI"/>
+              </a:rPr>
+              <a:t>“You need a passport or a national ID to complete the registration process.”</a:t>
+            </a:r>
+          </a:p>
+          <a:p>
+            <a:pPr algn="l">
+              <a:lnSpc>
+                <a:spcPct val="95000"/>
+              </a:lnSpc>
+              <a:spcBef>
+                <a:spcPts val="0"/>
+              </a:spcBef>
+              <a:spcAft>
+                <a:spcPts val="0"/>
+              </a:spcAft>
+            </a:pPr>
+            <a:r>
+              <a:rPr lang="en-US" sz="1200" b="1" i="0" dirty="0">
+                <a:solidFill>
+                  <a:srgbClr val="0E8F7E"/>
+                </a:solidFill>
+                <a:latin typeface="Segoe UI"/>
+                <a:cs typeface="Segoe UI"/>
+              </a:rPr>
+              <a:t>Bringing both is no problem. → </a:t>
+            </a:r>
+            <a:r>
+              <a:rPr lang="en-US" sz="1300" b="1" i="0" dirty="0">
+                <a:solidFill>
+                  <a:srgbClr val="1F6FB2"/>
+                </a:solidFill>
+                <a:latin typeface="Cambria Math"/>
+                <a:cs typeface="Cambria Math"/>
+              </a:rPr>
+              <a:t>∨</a:t>
+            </a:r>
+          </a:p>
+        </p:txBody>
+      </p:sp>
+      <p:sp>
+        <p:nvSpPr>
+          <p:cNvPr id="112" name="Shape 112"/>
+          <p:cNvSpPr/>
+          <p:nvPr/>
+        </p:nvSpPr>
+        <p:spPr>
+          <a:xfrm>
+            <a:off x="658368" y="5230368"/>
+            <a:ext cx="5163159" cy="868680"/>
+          </a:xfrm>
+          <a:prstGeom prst="roundRect">
+            <a:avLst>
+              <a:gd name="adj" fmla="val 6000"/>
+            </a:avLst>
+          </a:prstGeom>
+          <a:solidFill>
+            <a:srgbClr val="F3F7FA"/>
+          </a:solidFill>
+          <a:ln w="12700">
+            <a:solidFill>
+              <a:srgbClr val="D7E1EA"/>
+            </a:solidFill>
+          </a:ln>
+          <a:effectLst/>
+        </p:spPr>
+        <p:style>
+          <a:lnRef idx="1">
+            <a:schemeClr val="accent1"/>
+          </a:lnRef>
+          <a:fillRef idx="3">
+            <a:schemeClr val="accent1"/>
+          </a:fillRef>
+          <a:effectRef idx="2">
+            <a:schemeClr val="accent1"/>
+          </a:effectRef>
+          <a:fontRef idx="minor">
+            <a:schemeClr val="lt1"/>
+          </a:fontRef>
+        </p:style>
+        <p:txBody>
+          <a:bodyPr wrap="square" rtlCol="0" anchor="ctr"/>
+          <a:lstStyle/>
+          <a:p>
+            <a:pPr algn="ctr"/>
+            <a:endParaRPr/>
+          </a:p>
+        </p:txBody>
+      </p:sp>
+      <p:sp>
+        <p:nvSpPr>
+          <p:cNvPr id="113" name="Shape 113"/>
+          <p:cNvSpPr/>
+          <p:nvPr/>
+        </p:nvSpPr>
+        <p:spPr>
+          <a:xfrm>
+            <a:off x="658368" y="5230368"/>
+            <a:ext cx="64008" cy="868680"/>
+          </a:xfrm>
+          <a:prstGeom prst="rect">
+            <a:avLst/>
+          </a:prstGeom>
+          <a:solidFill>
+            <a:srgbClr val="0E8F7E"/>
+          </a:solidFill>
+          <a:ln>
+            <a:noFill/>
+          </a:ln>
+          <a:effectLst/>
+        </p:spPr>
+        <p:style>
+          <a:lnRef idx="1">
+            <a:schemeClr val="accent1"/>
+          </a:lnRef>
+          <a:fillRef idx="3">
+            <a:schemeClr val="accent1"/>
+          </a:fillRef>
+          <a:effectRef idx="2">
+            <a:schemeClr val="accent1"/>
+          </a:effectRef>
+          <a:fontRef idx="minor">
+            <a:schemeClr val="lt1"/>
+          </a:fontRef>
+        </p:style>
+        <p:txBody>
+          <a:bodyPr wrap="square" rtlCol="0" anchor="ctr"/>
+          <a:lstStyle/>
+          <a:p>
+            <a:pPr algn="ctr"/>
+            <a:endParaRPr/>
+          </a:p>
+        </p:txBody>
+      </p:sp>
+      <p:sp>
+        <p:nvSpPr>
+          <p:cNvPr id="114" name="TextBox 114"/>
+          <p:cNvSpPr txBox="1"/>
+          <p:nvPr/>
+        </p:nvSpPr>
+        <p:spPr>
+          <a:xfrm>
+            <a:off x="932688" y="5230368"/>
+            <a:ext cx="4705959" cy="868680"/>
+          </a:xfrm>
+          <a:prstGeom prst="rect">
+            <a:avLst/>
+          </a:prstGeom>
+          <a:noFill/>
+        </p:spPr>
+        <p:txBody>
+          <a:bodyPr wrap="square" lIns="0" tIns="0" rIns="0" bIns="0" anchor="ctr">
+            <a:normAutofit/>
+          </a:bodyPr>
+          <a:lstStyle/>
+          <a:p>
+            <a:pPr algn="l">
+              <a:lnSpc>
+                <a:spcPct val="95000"/>
+              </a:lnSpc>
+              <a:spcBef>
+                <a:spcPts val="0"/>
+              </a:spcBef>
+              <a:spcAft>
+                <a:spcPts val="300"/>
+              </a:spcAft>
+            </a:pPr>
+            <a:r>
+              <a:rPr lang="en-US" sz="1350" b="0" i="0" dirty="0">
+                <a:solidFill>
+                  <a:srgbClr val="1B2D3E"/>
+                </a:solidFill>
+                <a:latin typeface="Segoe UI"/>
+                <a:cs typeface="Segoe UI"/>
+              </a:rPr>
+              <a:t>“Students can learn Python or Java in the first year.”</a:t>
+            </a:r>
+          </a:p>
+          <a:p>
+            <a:pPr algn="l">
+              <a:lnSpc>
+                <a:spcPct val="95000"/>
+              </a:lnSpc>
+              <a:spcBef>
+                <a:spcPts val="0"/>
+              </a:spcBef>
+              <a:spcAft>
+                <a:spcPts val="0"/>
+              </a:spcAft>
+            </a:pPr>
+            <a:r>
+              <a:rPr lang="en-US" sz="1200" b="1" i="0" dirty="0">
+                <a:solidFill>
+                  <a:srgbClr val="0E8F7E"/>
+                </a:solidFill>
+                <a:latin typeface="Segoe UI"/>
+                <a:cs typeface="Segoe UI"/>
+              </a:rPr>
+              <a:t>Learning both is allowed. → </a:t>
+            </a:r>
+            <a:r>
+              <a:rPr lang="en-US" sz="1300" b="1" i="0" dirty="0">
+                <a:solidFill>
+                  <a:srgbClr val="1F6FB2"/>
+                </a:solidFill>
+                <a:latin typeface="Cambria Math"/>
+                <a:cs typeface="Cambria Math"/>
+              </a:rPr>
+              <a:t>∨</a:t>
+            </a:r>
+          </a:p>
+        </p:txBody>
+      </p:sp>
+      <p:sp>
+        <p:nvSpPr>
+          <p:cNvPr id="115" name="Shape 115"/>
+          <p:cNvSpPr/>
+          <p:nvPr/>
+        </p:nvSpPr>
+        <p:spPr>
+          <a:xfrm>
+            <a:off x="6370167" y="1600200"/>
+            <a:ext cx="5163159" cy="640080"/>
+          </a:xfrm>
+          <a:prstGeom prst="roundRect">
+            <a:avLst>
+              <a:gd name="adj" fmla="val 6000"/>
+            </a:avLst>
+          </a:prstGeom>
+          <a:solidFill>
+            <a:srgbClr val="F2EFFA"/>
+          </a:solidFill>
+          <a:ln>
+            <a:noFill/>
+          </a:ln>
+          <a:effectLst/>
+        </p:spPr>
+        <p:style>
+          <a:lnRef idx="1">
+            <a:schemeClr val="accent1"/>
+          </a:lnRef>
+          <a:fillRef idx="3">
+            <a:schemeClr val="accent1"/>
+          </a:fillRef>
+          <a:effectRef idx="2">
+            <a:schemeClr val="accent1"/>
+          </a:effectRef>
+          <a:fontRef idx="minor">
+            <a:schemeClr val="lt1"/>
+          </a:fontRef>
+        </p:style>
+        <p:txBody>
+          <a:bodyPr wrap="square" rtlCol="0" anchor="ctr"/>
+          <a:lstStyle/>
+          <a:p>
+            <a:pPr algn="ctr"/>
+            <a:endParaRPr/>
+          </a:p>
+        </p:txBody>
+      </p:sp>
+      <p:sp>
+        <p:nvSpPr>
+          <p:cNvPr id="116" name="TextBox 116"/>
+          <p:cNvSpPr txBox="1"/>
+          <p:nvPr/>
+        </p:nvSpPr>
+        <p:spPr>
+          <a:xfrm>
+            <a:off x="6690207" y="1600200"/>
+            <a:ext cx="4523079" cy="640080"/>
+          </a:xfrm>
+          <a:prstGeom prst="rect">
+            <a:avLst/>
+          </a:prstGeom>
+          <a:noFill/>
+        </p:spPr>
+        <p:txBody>
+          <a:bodyPr wrap="square" lIns="0" tIns="0" rIns="0" bIns="0" anchor="ctr">
+            <a:normAutofit/>
+          </a:bodyPr>
+          <a:lstStyle/>
+          <a:p>
+            <a:pPr algn="l">
+              <a:lnSpc>
+                <a:spcPct val="95000"/>
+              </a:lnSpc>
+              <a:spcBef>
+                <a:spcPts val="0"/>
+              </a:spcBef>
+              <a:spcAft>
+                <a:spcPts val="0"/>
+              </a:spcAft>
+            </a:pPr>
+            <a:r>
+              <a:rPr lang="en-US" sz="1700" b="1" i="0" dirty="0">
+                <a:solidFill>
+                  <a:srgbClr val="6B4EA8"/>
+                </a:solidFill>
+                <a:latin typeface="Segoe UI"/>
+                <a:cs typeface="Segoe UI"/>
+              </a:rPr>
+              <a:t>Exclusive  </a:t>
+            </a:r>
+            <a:r>
+              <a:rPr lang="en-US" sz="1800" b="1" i="0" dirty="0">
+                <a:solidFill>
+                  <a:srgbClr val="1F6FB2"/>
+                </a:solidFill>
+                <a:latin typeface="Cambria Math"/>
+                <a:cs typeface="Cambria Math"/>
+              </a:rPr>
+              <a:t>⊕</a:t>
+            </a:r>
+            <a:r>
+              <a:rPr lang="en-US" sz="1300" b="0" i="0" dirty="0">
+                <a:solidFill>
+                  <a:srgbClr val="1B2D3E"/>
+                </a:solidFill>
+                <a:latin typeface="Segoe UI"/>
+                <a:cs typeface="Segoe UI"/>
+              </a:rPr>
+              <a:t>   “exactly one” — not both</a:t>
+            </a:r>
+          </a:p>
+        </p:txBody>
+      </p:sp>
+      <p:sp>
+        <p:nvSpPr>
+          <p:cNvPr id="117" name="Shape 117"/>
+          <p:cNvSpPr/>
+          <p:nvPr/>
+        </p:nvSpPr>
+        <p:spPr>
+          <a:xfrm>
+            <a:off x="6370167" y="2377440"/>
+            <a:ext cx="5163159" cy="868680"/>
+          </a:xfrm>
+          <a:prstGeom prst="roundRect">
+            <a:avLst>
+              <a:gd name="adj" fmla="val 6000"/>
+            </a:avLst>
+          </a:prstGeom>
+          <a:solidFill>
+            <a:srgbClr val="FFFFFF"/>
+          </a:solidFill>
+          <a:ln w="12700">
+            <a:solidFill>
+              <a:srgbClr val="D7E1EA"/>
+            </a:solidFill>
+          </a:ln>
+          <a:effectLst/>
+        </p:spPr>
+        <p:style>
+          <a:lnRef idx="1">
+            <a:schemeClr val="accent1"/>
+          </a:lnRef>
+          <a:fillRef idx="3">
+            <a:schemeClr val="accent1"/>
+          </a:fillRef>
+          <a:effectRef idx="2">
+            <a:schemeClr val="accent1"/>
+          </a:effectRef>
+          <a:fontRef idx="minor">
+            <a:schemeClr val="lt1"/>
+          </a:fontRef>
+        </p:style>
+        <p:txBody>
+          <a:bodyPr wrap="square" rtlCol="0" anchor="ctr"/>
+          <a:lstStyle/>
+          <a:p>
+            <a:pPr algn="ctr"/>
+            <a:endParaRPr/>
+          </a:p>
+        </p:txBody>
+      </p:sp>
+      <p:sp>
+        <p:nvSpPr>
+          <p:cNvPr id="118" name="Shape 118"/>
+          <p:cNvSpPr/>
+          <p:nvPr/>
+        </p:nvSpPr>
+        <p:spPr>
+          <a:xfrm>
+            <a:off x="6370167" y="2377440"/>
+            <a:ext cx="64008" cy="868680"/>
+          </a:xfrm>
+          <a:prstGeom prst="rect">
+            <a:avLst/>
+          </a:prstGeom>
+          <a:solidFill>
+            <a:srgbClr val="6B4EA8"/>
+          </a:solidFill>
+          <a:ln>
+            <a:noFill/>
+          </a:ln>
+          <a:effectLst/>
+        </p:spPr>
+        <p:style>
+          <a:lnRef idx="1">
+            <a:schemeClr val="accent1"/>
+          </a:lnRef>
+          <a:fillRef idx="3">
+            <a:schemeClr val="accent1"/>
+          </a:fillRef>
+          <a:effectRef idx="2">
+            <a:schemeClr val="accent1"/>
+          </a:effectRef>
+          <a:fontRef idx="minor">
+            <a:schemeClr val="lt1"/>
+          </a:fontRef>
+        </p:style>
+        <p:txBody>
+          <a:bodyPr wrap="square" rtlCol="0" anchor="ctr"/>
+          <a:lstStyle/>
+          <a:p>
+            <a:pPr algn="ctr"/>
+            <a:endParaRPr/>
+          </a:p>
+        </p:txBody>
+      </p:sp>
+      <p:sp>
+        <p:nvSpPr>
+          <p:cNvPr id="119" name="TextBox 119"/>
+          <p:cNvSpPr txBox="1"/>
+          <p:nvPr/>
+        </p:nvSpPr>
+        <p:spPr>
+          <a:xfrm>
+            <a:off x="6644487" y="2377440"/>
+            <a:ext cx="4705959" cy="868680"/>
+          </a:xfrm>
+          <a:prstGeom prst="rect">
+            <a:avLst/>
+          </a:prstGeom>
+          <a:noFill/>
+        </p:spPr>
+        <p:txBody>
+          <a:bodyPr wrap="square" lIns="0" tIns="0" rIns="0" bIns="0" anchor="ctr">
+            <a:normAutofit/>
+          </a:bodyPr>
+          <a:lstStyle/>
+          <a:p>
+            <a:pPr algn="l">
+              <a:lnSpc>
+                <a:spcPct val="95000"/>
+              </a:lnSpc>
+              <a:spcBef>
+                <a:spcPts val="0"/>
+              </a:spcBef>
+              <a:spcAft>
+                <a:spcPts val="300"/>
+              </a:spcAft>
+            </a:pPr>
+            <a:r>
+              <a:rPr lang="en-US" sz="1350" b="0" i="0" dirty="0">
+                <a:solidFill>
+                  <a:srgbClr val="1B2D3E"/>
+                </a:solidFill>
+                <a:latin typeface="Segoe UI"/>
+                <a:cs typeface="Segoe UI"/>
+              </a:rPr>
+              <a:t>“Tamim or Shakib will be the next captain of the national cricket team.”</a:t>
+            </a:r>
+          </a:p>
+          <a:p>
+            <a:pPr algn="l">
+              <a:lnSpc>
+                <a:spcPct val="95000"/>
+              </a:lnSpc>
+              <a:spcBef>
+                <a:spcPts val="0"/>
+              </a:spcBef>
+              <a:spcAft>
+                <a:spcPts val="0"/>
+              </a:spcAft>
+            </a:pPr>
+            <a:r>
+              <a:rPr lang="en-US" sz="1200" b="1" i="0" dirty="0">
+                <a:solidFill>
+                  <a:srgbClr val="6B4EA8"/>
+                </a:solidFill>
+                <a:latin typeface="Segoe UI"/>
+                <a:cs typeface="Segoe UI"/>
+              </a:rPr>
+              <a:t>Only one captain at a time. → </a:t>
+            </a:r>
+            <a:r>
+              <a:rPr lang="en-US" sz="1300" b="1" i="0" dirty="0">
+                <a:solidFill>
+                  <a:srgbClr val="1F6FB2"/>
+                </a:solidFill>
+                <a:latin typeface="Cambria Math"/>
+                <a:cs typeface="Cambria Math"/>
+              </a:rPr>
+              <a:t>⊕</a:t>
+            </a:r>
+          </a:p>
+        </p:txBody>
+      </p:sp>
+      <p:sp>
+        <p:nvSpPr>
+          <p:cNvPr id="120" name="Shape 120"/>
+          <p:cNvSpPr/>
+          <p:nvPr/>
+        </p:nvSpPr>
+        <p:spPr>
+          <a:xfrm>
+            <a:off x="6370167" y="3328416"/>
+            <a:ext cx="5163159" cy="868680"/>
+          </a:xfrm>
+          <a:prstGeom prst="roundRect">
+            <a:avLst>
+              <a:gd name="adj" fmla="val 6000"/>
+            </a:avLst>
+          </a:prstGeom>
+          <a:solidFill>
+            <a:srgbClr val="F3F7FA"/>
+          </a:solidFill>
+          <a:ln w="12700">
+            <a:solidFill>
+              <a:srgbClr val="D7E1EA"/>
+            </a:solidFill>
+          </a:ln>
+          <a:effectLst/>
+        </p:spPr>
+        <p:style>
+          <a:lnRef idx="1">
+            <a:schemeClr val="accent1"/>
+          </a:lnRef>
+          <a:fillRef idx="3">
+            <a:schemeClr val="accent1"/>
+          </a:fillRef>
+          <a:effectRef idx="2">
+            <a:schemeClr val="accent1"/>
+          </a:effectRef>
+          <a:fontRef idx="minor">
+            <a:schemeClr val="lt1"/>
+          </a:fontRef>
+        </p:style>
+        <p:txBody>
+          <a:bodyPr wrap="square" rtlCol="0" anchor="ctr"/>
+          <a:lstStyle/>
+          <a:p>
+            <a:pPr algn="ctr"/>
+            <a:endParaRPr/>
+          </a:p>
+        </p:txBody>
+      </p:sp>
+      <p:sp>
+        <p:nvSpPr>
+          <p:cNvPr id="121" name="Shape 121"/>
+          <p:cNvSpPr/>
+          <p:nvPr/>
+        </p:nvSpPr>
+        <p:spPr>
+          <a:xfrm>
+            <a:off x="6370167" y="3328416"/>
+            <a:ext cx="64008" cy="868680"/>
+          </a:xfrm>
+          <a:prstGeom prst="rect">
+            <a:avLst/>
+          </a:prstGeom>
+          <a:solidFill>
+            <a:srgbClr val="6B4EA8"/>
+          </a:solidFill>
+          <a:ln>
+            <a:noFill/>
+          </a:ln>
+          <a:effectLst/>
+        </p:spPr>
+        <p:style>
+          <a:lnRef idx="1">
+            <a:schemeClr val="accent1"/>
+          </a:lnRef>
+          <a:fillRef idx="3">
+            <a:schemeClr val="accent1"/>
+          </a:fillRef>
+          <a:effectRef idx="2">
+            <a:schemeClr val="accent1"/>
+          </a:effectRef>
+          <a:fontRef idx="minor">
+            <a:schemeClr val="lt1"/>
+          </a:fontRef>
+        </p:style>
+        <p:txBody>
+          <a:bodyPr wrap="square" rtlCol="0" anchor="ctr"/>
+          <a:lstStyle/>
+          <a:p>
+            <a:pPr algn="ctr"/>
+            <a:endParaRPr/>
+          </a:p>
+        </p:txBody>
+      </p:sp>
+      <p:sp>
+        <p:nvSpPr>
+          <p:cNvPr id="122" name="TextBox 122"/>
+          <p:cNvSpPr txBox="1"/>
+          <p:nvPr/>
+        </p:nvSpPr>
+        <p:spPr>
+          <a:xfrm>
+            <a:off x="6644487" y="3328416"/>
+            <a:ext cx="4705959" cy="868680"/>
+          </a:xfrm>
+          <a:prstGeom prst="rect">
+            <a:avLst/>
+          </a:prstGeom>
+          <a:noFill/>
+        </p:spPr>
+        <p:txBody>
+          <a:bodyPr wrap="square" lIns="0" tIns="0" rIns="0" bIns="0" anchor="ctr">
+            <a:normAutofit/>
+          </a:bodyPr>
+          <a:lstStyle/>
+          <a:p>
+            <a:pPr algn="l">
+              <a:lnSpc>
+                <a:spcPct val="95000"/>
+              </a:lnSpc>
+              <a:spcBef>
+                <a:spcPts val="0"/>
+              </a:spcBef>
+              <a:spcAft>
+                <a:spcPts val="300"/>
+              </a:spcAft>
+            </a:pPr>
+            <a:r>
+              <a:rPr lang="en-US" sz="1350" b="0" i="0" dirty="0">
+                <a:solidFill>
+                  <a:srgbClr val="1B2D3E"/>
+                </a:solidFill>
+                <a:latin typeface="Segoe UI"/>
+                <a:cs typeface="Segoe UI"/>
+              </a:rPr>
+              <a:t>“The switch is ON or OFF.”</a:t>
+            </a:r>
+          </a:p>
+          <a:p>
+            <a:pPr algn="l">
+              <a:lnSpc>
+                <a:spcPct val="95000"/>
+              </a:lnSpc>
+              <a:spcBef>
+                <a:spcPts val="0"/>
+              </a:spcBef>
+              <a:spcAft>
+                <a:spcPts val="0"/>
+              </a:spcAft>
+            </a:pPr>
+            <a:r>
+              <a:rPr lang="en-US" sz="1200" b="1" i="0" dirty="0">
+                <a:solidFill>
+                  <a:srgbClr val="6B4EA8"/>
+                </a:solidFill>
+                <a:latin typeface="Segoe UI"/>
+                <a:cs typeface="Segoe UI"/>
+              </a:rPr>
+              <a:t>It can’t be both at once. → </a:t>
+            </a:r>
+            <a:r>
+              <a:rPr lang="en-US" sz="1300" b="1" i="0" dirty="0">
+                <a:solidFill>
+                  <a:srgbClr val="1F6FB2"/>
+                </a:solidFill>
+                <a:latin typeface="Cambria Math"/>
+                <a:cs typeface="Cambria Math"/>
+              </a:rPr>
+              <a:t>⊕</a:t>
+            </a:r>
+          </a:p>
+        </p:txBody>
+      </p:sp>
+      <p:sp>
+        <p:nvSpPr>
+          <p:cNvPr id="123" name="Shape 123"/>
+          <p:cNvSpPr/>
+          <p:nvPr/>
+        </p:nvSpPr>
+        <p:spPr>
+          <a:xfrm>
+            <a:off x="6370167" y="4279392"/>
+            <a:ext cx="5163159" cy="868680"/>
+          </a:xfrm>
+          <a:prstGeom prst="roundRect">
+            <a:avLst>
+              <a:gd name="adj" fmla="val 6000"/>
+            </a:avLst>
+          </a:prstGeom>
+          <a:solidFill>
+            <a:srgbClr val="FFFFFF"/>
+          </a:solidFill>
+          <a:ln w="12700">
+            <a:solidFill>
+              <a:srgbClr val="D7E1EA"/>
+            </a:solidFill>
+          </a:ln>
+          <a:effectLst/>
+        </p:spPr>
+        <p:style>
+          <a:lnRef idx="1">
+            <a:schemeClr val="accent1"/>
+          </a:lnRef>
+          <a:fillRef idx="3">
+            <a:schemeClr val="accent1"/>
+          </a:fillRef>
+          <a:effectRef idx="2">
+            <a:schemeClr val="accent1"/>
+          </a:effectRef>
+          <a:fontRef idx="minor">
+            <a:schemeClr val="lt1"/>
+          </a:fontRef>
+        </p:style>
+        <p:txBody>
+          <a:bodyPr wrap="square" rtlCol="0" anchor="ctr"/>
+          <a:lstStyle/>
+          <a:p>
+            <a:pPr algn="ctr"/>
+            <a:endParaRPr/>
+          </a:p>
+        </p:txBody>
+      </p:sp>
+      <p:sp>
+        <p:nvSpPr>
+          <p:cNvPr id="124" name="Shape 124"/>
+          <p:cNvSpPr/>
+          <p:nvPr/>
+        </p:nvSpPr>
+        <p:spPr>
+          <a:xfrm>
+            <a:off x="6370167" y="4279392"/>
+            <a:ext cx="64008" cy="868680"/>
+          </a:xfrm>
+          <a:prstGeom prst="rect">
+            <a:avLst/>
+          </a:prstGeom>
+          <a:solidFill>
+            <a:srgbClr val="6B4EA8"/>
+          </a:solidFill>
+          <a:ln>
+            <a:noFill/>
+          </a:ln>
+          <a:effectLst/>
+        </p:spPr>
+        <p:style>
+          <a:lnRef idx="1">
+            <a:schemeClr val="accent1"/>
+          </a:lnRef>
+          <a:fillRef idx="3">
+            <a:schemeClr val="accent1"/>
+          </a:fillRef>
+          <a:effectRef idx="2">
+            <a:schemeClr val="accent1"/>
+          </a:effectRef>
+          <a:fontRef idx="minor">
+            <a:schemeClr val="lt1"/>
+          </a:fontRef>
+        </p:style>
+        <p:txBody>
+          <a:bodyPr wrap="square" rtlCol="0" anchor="ctr"/>
+          <a:lstStyle/>
+          <a:p>
+            <a:pPr algn="ctr"/>
+            <a:endParaRPr/>
+          </a:p>
+        </p:txBody>
+      </p:sp>
+      <p:sp>
+        <p:nvSpPr>
+          <p:cNvPr id="125" name="TextBox 125"/>
+          <p:cNvSpPr txBox="1"/>
+          <p:nvPr/>
+        </p:nvSpPr>
+        <p:spPr>
+          <a:xfrm>
+            <a:off x="6644487" y="4279392"/>
+            <a:ext cx="4705959" cy="868680"/>
+          </a:xfrm>
+          <a:prstGeom prst="rect">
+            <a:avLst/>
+          </a:prstGeom>
+          <a:noFill/>
+        </p:spPr>
+        <p:txBody>
+          <a:bodyPr wrap="square" lIns="0" tIns="0" rIns="0" bIns="0" anchor="ctr">
+            <a:normAutofit/>
+          </a:bodyPr>
+          <a:lstStyle/>
+          <a:p>
+            <a:pPr algn="l">
+              <a:lnSpc>
+                <a:spcPct val="95000"/>
+              </a:lnSpc>
+              <a:spcBef>
+                <a:spcPts val="0"/>
+              </a:spcBef>
+              <a:spcAft>
+                <a:spcPts val="300"/>
+              </a:spcAft>
+            </a:pPr>
+            <a:r>
+              <a:rPr lang="en-US" sz="1350" b="0" i="0" dirty="0">
+                <a:solidFill>
+                  <a:srgbClr val="1B2D3E"/>
+                </a:solidFill>
+                <a:latin typeface="Segoe UI"/>
+                <a:cs typeface="Segoe UI"/>
+              </a:rPr>
+              <a:t>“A student will pass or fail the examination.”</a:t>
+            </a:r>
+          </a:p>
+          <a:p>
+            <a:pPr algn="l">
+              <a:lnSpc>
+                <a:spcPct val="95000"/>
+              </a:lnSpc>
+              <a:spcBef>
+                <a:spcPts val="0"/>
+              </a:spcBef>
+              <a:spcAft>
+                <a:spcPts val="0"/>
+              </a:spcAft>
+            </a:pPr>
+            <a:r>
+              <a:rPr lang="en-US" sz="1200" b="1" i="0" dirty="0">
+                <a:solidFill>
+                  <a:srgbClr val="6B4EA8"/>
+                </a:solidFill>
+                <a:latin typeface="Segoe UI"/>
+                <a:cs typeface="Segoe UI"/>
+              </a:rPr>
+              <a:t>Both results can’t happen together. → </a:t>
+            </a:r>
+            <a:r>
+              <a:rPr lang="en-US" sz="1300" b="1" i="0" dirty="0">
+                <a:solidFill>
+                  <a:srgbClr val="1F6FB2"/>
+                </a:solidFill>
+                <a:latin typeface="Cambria Math"/>
+                <a:cs typeface="Cambria Math"/>
+              </a:rPr>
+              <a:t>⊕</a:t>
+            </a:r>
+          </a:p>
+        </p:txBody>
+      </p:sp>
+      <p:sp>
+        <p:nvSpPr>
+          <p:cNvPr id="126" name="Shape 126"/>
+          <p:cNvSpPr/>
+          <p:nvPr/>
+        </p:nvSpPr>
+        <p:spPr>
+          <a:xfrm>
+            <a:off x="6370167" y="5230368"/>
+            <a:ext cx="5163159" cy="868680"/>
+          </a:xfrm>
+          <a:prstGeom prst="roundRect">
+            <a:avLst>
+              <a:gd name="adj" fmla="val 6000"/>
+            </a:avLst>
+          </a:prstGeom>
+          <a:solidFill>
+            <a:srgbClr val="F3F7FA"/>
+          </a:solidFill>
+          <a:ln w="12700">
+            <a:solidFill>
+              <a:srgbClr val="D7E1EA"/>
+            </a:solidFill>
+          </a:ln>
+          <a:effectLst/>
+        </p:spPr>
+        <p:style>
+          <a:lnRef idx="1">
+            <a:schemeClr val="accent1"/>
+          </a:lnRef>
+          <a:fillRef idx="3">
+            <a:schemeClr val="accent1"/>
+          </a:fillRef>
+          <a:effectRef idx="2">
+            <a:schemeClr val="accent1"/>
+          </a:effectRef>
+          <a:fontRef idx="minor">
+            <a:schemeClr val="lt1"/>
+          </a:fontRef>
+        </p:style>
+        <p:txBody>
+          <a:bodyPr wrap="square" rtlCol="0" anchor="ctr"/>
+          <a:lstStyle/>
+          <a:p>
+            <a:pPr algn="ctr"/>
+            <a:endParaRPr/>
+          </a:p>
+        </p:txBody>
+      </p:sp>
+      <p:sp>
+        <p:nvSpPr>
+          <p:cNvPr id="127" name="Shape 127"/>
+          <p:cNvSpPr/>
+          <p:nvPr/>
+        </p:nvSpPr>
+        <p:spPr>
+          <a:xfrm>
+            <a:off x="6370167" y="5230368"/>
+            <a:ext cx="64008" cy="868680"/>
+          </a:xfrm>
+          <a:prstGeom prst="rect">
+            <a:avLst/>
+          </a:prstGeom>
+          <a:solidFill>
+            <a:srgbClr val="6B4EA8"/>
+          </a:solidFill>
+          <a:ln>
+            <a:noFill/>
+          </a:ln>
+          <a:effectLst/>
+        </p:spPr>
+        <p:style>
+          <a:lnRef idx="1">
+            <a:schemeClr val="accent1"/>
+          </a:lnRef>
+          <a:fillRef idx="3">
+            <a:schemeClr val="accent1"/>
+          </a:fillRef>
+          <a:effectRef idx="2">
+            <a:schemeClr val="accent1"/>
+          </a:effectRef>
+          <a:fontRef idx="minor">
+            <a:schemeClr val="lt1"/>
+          </a:fontRef>
+        </p:style>
+        <p:txBody>
+          <a:bodyPr wrap="square" rtlCol="0" anchor="ctr"/>
+          <a:lstStyle/>
+          <a:p>
+            <a:pPr algn="ctr"/>
+            <a:endParaRPr/>
+          </a:p>
+        </p:txBody>
+      </p:sp>
+      <p:sp>
+        <p:nvSpPr>
+          <p:cNvPr id="128" name="TextBox 128"/>
+          <p:cNvSpPr txBox="1"/>
+          <p:nvPr/>
+        </p:nvSpPr>
+        <p:spPr>
+          <a:xfrm>
+            <a:off x="6644487" y="5230368"/>
+            <a:ext cx="4705959" cy="868680"/>
+          </a:xfrm>
+          <a:prstGeom prst="rect">
+            <a:avLst/>
+          </a:prstGeom>
+          <a:noFill/>
+        </p:spPr>
+        <p:txBody>
+          <a:bodyPr wrap="square" lIns="0" tIns="0" rIns="0" bIns="0" anchor="ctr">
+            <a:normAutofit/>
+          </a:bodyPr>
+          <a:lstStyle/>
+          <a:p>
+            <a:pPr algn="l">
+              <a:lnSpc>
+                <a:spcPct val="95000"/>
+              </a:lnSpc>
+              <a:spcBef>
+                <a:spcPts val="0"/>
+              </a:spcBef>
+              <a:spcAft>
+                <a:spcPts val="300"/>
+              </a:spcAft>
+            </a:pPr>
+            <a:r>
+              <a:rPr lang="en-US" sz="1350" b="0" i="0" dirty="0">
+                <a:solidFill>
+                  <a:srgbClr val="1B2D3E"/>
+                </a:solidFill>
+                <a:latin typeface="Segoe UI"/>
+                <a:cs typeface="Segoe UI"/>
+              </a:rPr>
+              <a:t>“The coin will land on heads or tails.”</a:t>
+            </a:r>
+          </a:p>
+          <a:p>
+            <a:pPr algn="l">
+              <a:lnSpc>
+                <a:spcPct val="95000"/>
+              </a:lnSpc>
+              <a:spcBef>
+                <a:spcPts val="0"/>
+              </a:spcBef>
+              <a:spcAft>
+                <a:spcPts val="0"/>
+              </a:spcAft>
+            </a:pPr>
+            <a:r>
+              <a:rPr lang="en-US" sz="1200" b="1" i="0" dirty="0">
+                <a:solidFill>
+                  <a:srgbClr val="6B4EA8"/>
+                </a:solidFill>
+                <a:latin typeface="Segoe UI"/>
+                <a:cs typeface="Segoe UI"/>
+              </a:rPr>
+              <a:t>Exactly one face lands up. → </a:t>
+            </a:r>
+            <a:r>
+              <a:rPr lang="en-US" sz="1300" b="1" i="0" dirty="0">
+                <a:solidFill>
+                  <a:srgbClr val="1F6FB2"/>
+                </a:solidFill>
+                <a:latin typeface="Cambria Math"/>
+                <a:cs typeface="Cambria Math"/>
+              </a:rPr>
+              <a:t>⊕</a:t>
+            </a:r>
           </a:p>
         </p:txBody>
       </p:sp>

</xml_diff>